<commit_message>
Run P0-10 near-limit source through local PPT production
</commit_message>
<xml_diff>
--- a/docs/product/ppt-benchmark-materials/PPT-P0-10/p0-10-reference.pptx
+++ b/docs/product/ppt-benchmark-materials/PPT-P0-10/p0-10-reference.pptx
@@ -1775,8 +1775,8 @@
         </p:nvSpPr>
         <p:spPr>
           <a:xfrm>
-            <a:off x="777240" y="5897880"/>
-            <a:ext cx="10607040" cy="411480"/>
+            <a:off x="777240" y="5760720"/>
+            <a:ext cx="10607040" cy="228600"/>
           </a:xfrm>
           <a:prstGeom prst="rect">
             <a:avLst/>
@@ -1814,7 +1814,7 @@
         </p:nvSpPr>
         <p:spPr>
           <a:xfrm>
-            <a:off x="777240" y="6263640"/>
+            <a:off x="777240" y="6099048"/>
             <a:ext cx="10607040" cy="182880"/>
           </a:xfrm>
           <a:prstGeom prst="rect">
@@ -1863,10 +1863,10 @@
           <a:ln/>
         </p:spPr>
         <p:txBody>
-          <a:bodyPr wrap="square" lIns="0" tIns="0" rIns="0" bIns="0" rtlCol="0" anchor="ctr"/>
-          <a:lstStyle/>
-          <a:p>
-            <a:pPr indent="0" marL="0">
+          <a:bodyPr wrap="square" lIns="0" tIns="0" rIns="0" bIns="0" rtlCol="0" anchor="t"/>
+          <a:lstStyle/>
+          <a:p>
+            <a:pPr algn="l" indent="0" marL="0">
               <a:buNone/>
             </a:pPr>
             <a:r>
@@ -2119,8 +2119,8 @@
         </p:nvSpPr>
         <p:spPr>
           <a:xfrm>
-            <a:off x="777240" y="5897880"/>
-            <a:ext cx="10607040" cy="411480"/>
+            <a:off x="777240" y="5760720"/>
+            <a:ext cx="10607040" cy="228600"/>
           </a:xfrm>
           <a:prstGeom prst="rect">
             <a:avLst/>
@@ -2158,7 +2158,7 @@
         </p:nvSpPr>
         <p:spPr>
           <a:xfrm>
-            <a:off x="777240" y="6263640"/>
+            <a:off x="777240" y="6099048"/>
             <a:ext cx="10607040" cy="182880"/>
           </a:xfrm>
           <a:prstGeom prst="rect">
@@ -2207,10 +2207,10 @@
           <a:ln/>
         </p:spPr>
         <p:txBody>
-          <a:bodyPr wrap="square" lIns="0" tIns="0" rIns="0" bIns="0" rtlCol="0" anchor="ctr"/>
-          <a:lstStyle/>
-          <a:p>
-            <a:pPr indent="0" marL="0">
+          <a:bodyPr wrap="square" lIns="0" tIns="0" rIns="0" bIns="0" rtlCol="0" anchor="t"/>
+          <a:lstStyle/>
+          <a:p>
+            <a:pPr algn="l" indent="0" marL="0">
               <a:buNone/>
             </a:pPr>
             <a:r>
@@ -2463,8 +2463,8 @@
         </p:nvSpPr>
         <p:spPr>
           <a:xfrm>
-            <a:off x="777240" y="5897880"/>
-            <a:ext cx="10607040" cy="411480"/>
+            <a:off x="777240" y="5760720"/>
+            <a:ext cx="10607040" cy="228600"/>
           </a:xfrm>
           <a:prstGeom prst="rect">
             <a:avLst/>
@@ -2502,7 +2502,7 @@
         </p:nvSpPr>
         <p:spPr>
           <a:xfrm>
-            <a:off x="777240" y="6263640"/>
+            <a:off x="777240" y="6099048"/>
             <a:ext cx="10607040" cy="182880"/>
           </a:xfrm>
           <a:prstGeom prst="rect">
@@ -2551,10 +2551,10 @@
           <a:ln/>
         </p:spPr>
         <p:txBody>
-          <a:bodyPr wrap="square" lIns="0" tIns="0" rIns="0" bIns="0" rtlCol="0" anchor="ctr"/>
-          <a:lstStyle/>
-          <a:p>
-            <a:pPr indent="0" marL="0">
+          <a:bodyPr wrap="square" lIns="0" tIns="0" rIns="0" bIns="0" rtlCol="0" anchor="t"/>
+          <a:lstStyle/>
+          <a:p>
+            <a:pPr algn="l" indent="0" marL="0">
               <a:buNone/>
             </a:pPr>
             <a:r>
@@ -2807,8 +2807,8 @@
         </p:nvSpPr>
         <p:spPr>
           <a:xfrm>
-            <a:off x="777240" y="5897880"/>
-            <a:ext cx="10607040" cy="411480"/>
+            <a:off x="777240" y="5760720"/>
+            <a:ext cx="10607040" cy="228600"/>
           </a:xfrm>
           <a:prstGeom prst="rect">
             <a:avLst/>
@@ -2846,7 +2846,7 @@
         </p:nvSpPr>
         <p:spPr>
           <a:xfrm>
-            <a:off x="777240" y="6263640"/>
+            <a:off x="777240" y="6099048"/>
             <a:ext cx="10607040" cy="182880"/>
           </a:xfrm>
           <a:prstGeom prst="rect">
@@ -2895,10 +2895,10 @@
           <a:ln/>
         </p:spPr>
         <p:txBody>
-          <a:bodyPr wrap="square" lIns="0" tIns="0" rIns="0" bIns="0" rtlCol="0" anchor="ctr"/>
-          <a:lstStyle/>
-          <a:p>
-            <a:pPr indent="0" marL="0">
+          <a:bodyPr wrap="square" lIns="0" tIns="0" rIns="0" bIns="0" rtlCol="0" anchor="t"/>
+          <a:lstStyle/>
+          <a:p>
+            <a:pPr algn="l" indent="0" marL="0">
               <a:buNone/>
             </a:pPr>
             <a:r>
@@ -3151,8 +3151,8 @@
         </p:nvSpPr>
         <p:spPr>
           <a:xfrm>
-            <a:off x="777240" y="5897880"/>
-            <a:ext cx="10607040" cy="411480"/>
+            <a:off x="777240" y="5760720"/>
+            <a:ext cx="10607040" cy="228600"/>
           </a:xfrm>
           <a:prstGeom prst="rect">
             <a:avLst/>
@@ -3190,7 +3190,7 @@
         </p:nvSpPr>
         <p:spPr>
           <a:xfrm>
-            <a:off x="777240" y="6263640"/>
+            <a:off x="777240" y="6099048"/>
             <a:ext cx="10607040" cy="182880"/>
           </a:xfrm>
           <a:prstGeom prst="rect">
@@ -3239,10 +3239,10 @@
           <a:ln/>
         </p:spPr>
         <p:txBody>
-          <a:bodyPr wrap="square" lIns="0" tIns="0" rIns="0" bIns="0" rtlCol="0" anchor="ctr"/>
-          <a:lstStyle/>
-          <a:p>
-            <a:pPr indent="0" marL="0">
+          <a:bodyPr wrap="square" lIns="0" tIns="0" rIns="0" bIns="0" rtlCol="0" anchor="t"/>
+          <a:lstStyle/>
+          <a:p>
+            <a:pPr algn="l" indent="0" marL="0">
               <a:buNone/>
             </a:pPr>
             <a:r>
@@ -3495,8 +3495,8 @@
         </p:nvSpPr>
         <p:spPr>
           <a:xfrm>
-            <a:off x="777240" y="5897880"/>
-            <a:ext cx="10607040" cy="411480"/>
+            <a:off x="777240" y="5760720"/>
+            <a:ext cx="10607040" cy="228600"/>
           </a:xfrm>
           <a:prstGeom prst="rect">
             <a:avLst/>
@@ -3534,7 +3534,7 @@
         </p:nvSpPr>
         <p:spPr>
           <a:xfrm>
-            <a:off x="777240" y="6263640"/>
+            <a:off x="777240" y="6099048"/>
             <a:ext cx="10607040" cy="182880"/>
           </a:xfrm>
           <a:prstGeom prst="rect">
@@ -3583,10 +3583,10 @@
           <a:ln/>
         </p:spPr>
         <p:txBody>
-          <a:bodyPr wrap="square" lIns="0" tIns="0" rIns="0" bIns="0" rtlCol="0" anchor="ctr"/>
-          <a:lstStyle/>
-          <a:p>
-            <a:pPr indent="0" marL="0">
+          <a:bodyPr wrap="square" lIns="0" tIns="0" rIns="0" bIns="0" rtlCol="0" anchor="t"/>
+          <a:lstStyle/>
+          <a:p>
+            <a:pPr algn="l" indent="0" marL="0">
               <a:buNone/>
             </a:pPr>
             <a:r>
@@ -3839,8 +3839,8 @@
         </p:nvSpPr>
         <p:spPr>
           <a:xfrm>
-            <a:off x="777240" y="5897880"/>
-            <a:ext cx="10607040" cy="411480"/>
+            <a:off x="777240" y="5760720"/>
+            <a:ext cx="10607040" cy="228600"/>
           </a:xfrm>
           <a:prstGeom prst="rect">
             <a:avLst/>
@@ -3878,7 +3878,7 @@
         </p:nvSpPr>
         <p:spPr>
           <a:xfrm>
-            <a:off x="777240" y="6263640"/>
+            <a:off x="777240" y="6099048"/>
             <a:ext cx="10607040" cy="182880"/>
           </a:xfrm>
           <a:prstGeom prst="rect">
@@ -3927,10 +3927,10 @@
           <a:ln/>
         </p:spPr>
         <p:txBody>
-          <a:bodyPr wrap="square" lIns="0" tIns="0" rIns="0" bIns="0" rtlCol="0" anchor="ctr"/>
-          <a:lstStyle/>
-          <a:p>
-            <a:pPr indent="0" marL="0">
+          <a:bodyPr wrap="square" lIns="0" tIns="0" rIns="0" bIns="0" rtlCol="0" anchor="t"/>
+          <a:lstStyle/>
+          <a:p>
+            <a:pPr algn="l" indent="0" marL="0">
               <a:buNone/>
             </a:pPr>
             <a:r>
@@ -4183,8 +4183,8 @@
         </p:nvSpPr>
         <p:spPr>
           <a:xfrm>
-            <a:off x="777240" y="5897880"/>
-            <a:ext cx="10607040" cy="411480"/>
+            <a:off x="777240" y="5760720"/>
+            <a:ext cx="10607040" cy="228600"/>
           </a:xfrm>
           <a:prstGeom prst="rect">
             <a:avLst/>
@@ -4222,7 +4222,7 @@
         </p:nvSpPr>
         <p:spPr>
           <a:xfrm>
-            <a:off x="777240" y="6263640"/>
+            <a:off x="777240" y="6099048"/>
             <a:ext cx="10607040" cy="182880"/>
           </a:xfrm>
           <a:prstGeom prst="rect">
@@ -4271,10 +4271,10 @@
           <a:ln/>
         </p:spPr>
         <p:txBody>
-          <a:bodyPr wrap="square" lIns="0" tIns="0" rIns="0" bIns="0" rtlCol="0" anchor="ctr"/>
-          <a:lstStyle/>
-          <a:p>
-            <a:pPr indent="0" marL="0">
+          <a:bodyPr wrap="square" lIns="0" tIns="0" rIns="0" bIns="0" rtlCol="0" anchor="t"/>
+          <a:lstStyle/>
+          <a:p>
+            <a:pPr algn="l" indent="0" marL="0">
               <a:buNone/>
             </a:pPr>
             <a:r>

</xml_diff>